<commit_message>
updating class_15 ppt and agenda
</commit_message>
<xml_diff>
--- a/docs/lectures/in-class_activities/class_15.pptx
+++ b/docs/lectures/in-class_activities/class_15.pptx
@@ -5,20 +5,18 @@
     <p:sldMasterId id="2147483648" r:id="rId1"/>
   </p:sldMasterIdLst>
   <p:notesMasterIdLst>
-    <p:notesMasterId r:id="rId13"/>
+    <p:notesMasterId r:id="rId11"/>
   </p:notesMasterIdLst>
   <p:sldIdLst>
     <p:sldId id="480" r:id="rId2"/>
     <p:sldId id="723" r:id="rId3"/>
-    <p:sldId id="1554" r:id="rId4"/>
-    <p:sldId id="712" r:id="rId5"/>
-    <p:sldId id="1561" r:id="rId6"/>
-    <p:sldId id="1562" r:id="rId7"/>
-    <p:sldId id="1563" r:id="rId8"/>
-    <p:sldId id="1564" r:id="rId9"/>
-    <p:sldId id="1557" r:id="rId10"/>
-    <p:sldId id="1558" r:id="rId11"/>
-    <p:sldId id="1560" r:id="rId12"/>
+    <p:sldId id="712" r:id="rId4"/>
+    <p:sldId id="1561" r:id="rId5"/>
+    <p:sldId id="1562" r:id="rId6"/>
+    <p:sldId id="1563" r:id="rId7"/>
+    <p:sldId id="1564" r:id="rId8"/>
+    <p:sldId id="1557" r:id="rId9"/>
+    <p:sldId id="1560" r:id="rId10"/>
   </p:sldIdLst>
   <p:sldSz cx="12192000" cy="6858000"/>
   <p:notesSz cx="6858000" cy="9144000"/>
@@ -207,7 +205,7 @@
           <a:p>
             <a:fld id="{6AC7DB66-C6D6-B24E-B345-FA3772C924EA}" type="datetimeFigureOut">
               <a:rPr lang="en-US" smtClean="0"/>
-              <a:t>11/3/21</a:t>
+              <a:t>11/3/25</a:t>
             </a:fld>
             <a:endParaRPr lang="en-US"/>
           </a:p>
@@ -558,197 +556,6 @@
 </p:notes>
 </file>
 
-<file path=ppt/notesSlides/notesSlide10.xml><?xml version="1.0" encoding="utf-8"?>
-<p:notes xmlns:a="http://schemas.openxmlformats.org/drawingml/2006/main" xmlns:r="http://schemas.openxmlformats.org/officeDocument/2006/relationships" xmlns:p="http://schemas.openxmlformats.org/presentationml/2006/main">
-  <p:cSld>
-    <p:spTree>
-      <p:nvGrpSpPr>
-        <p:cNvPr id="1" name=""/>
-        <p:cNvGrpSpPr/>
-        <p:nvPr/>
-      </p:nvGrpSpPr>
-      <p:grpSpPr>
-        <a:xfrm>
-          <a:off x="0" y="0"/>
-          <a:ext cx="0" cy="0"/>
-          <a:chOff x="0" y="0"/>
-          <a:chExt cx="0" cy="0"/>
-        </a:xfrm>
-      </p:grpSpPr>
-      <p:sp>
-        <p:nvSpPr>
-          <p:cNvPr id="2" name="Slide Image Placeholder 1"/>
-          <p:cNvSpPr>
-            <a:spLocks noGrp="1" noRot="1" noChangeAspect="1"/>
-          </p:cNvSpPr>
-          <p:nvPr>
-            <p:ph type="sldImg"/>
-          </p:nvPr>
-        </p:nvSpPr>
-        <p:spPr/>
-      </p:sp>
-      <p:sp>
-        <p:nvSpPr>
-          <p:cNvPr id="3" name="Notes Placeholder 2"/>
-          <p:cNvSpPr>
-            <a:spLocks noGrp="1"/>
-          </p:cNvSpPr>
-          <p:nvPr>
-            <p:ph type="body" idx="1"/>
-          </p:nvPr>
-        </p:nvSpPr>
-        <p:spPr/>
-        <p:txBody>
-          <a:bodyPr/>
-          <a:lstStyle/>
-          <a:p>
-            <a:endParaRPr lang="en-US" dirty="0"/>
-          </a:p>
-          <a:p>
-            <a:r>
-              <a:rPr lang="en-US" dirty="0"/>
-              <a:t>Changes in any attribute of a population over time. </a:t>
-            </a:r>
-          </a:p>
-          <a:p>
-            <a:r>
-              <a:rPr lang="en-US" dirty="0"/>
-              <a:t>Evolutionary</a:t>
-            </a:r>
-            <a:r>
-              <a:rPr lang="en-US" baseline="0" dirty="0"/>
-              <a:t> change leads to adaptation and must involve a change in the frequency of individual genes in a population from generation to generation.</a:t>
-            </a:r>
-            <a:endParaRPr lang="en-US" dirty="0"/>
-          </a:p>
-        </p:txBody>
-      </p:sp>
-      <p:sp>
-        <p:nvSpPr>
-          <p:cNvPr id="4" name="Slide Number Placeholder 3"/>
-          <p:cNvSpPr>
-            <a:spLocks noGrp="1"/>
-          </p:cNvSpPr>
-          <p:nvPr>
-            <p:ph type="sldNum" sz="quarter" idx="10"/>
-          </p:nvPr>
-        </p:nvSpPr>
-        <p:spPr/>
-        <p:txBody>
-          <a:bodyPr/>
-          <a:lstStyle/>
-          <a:p>
-            <a:pPr>
-              <a:defRPr/>
-            </a:pPr>
-            <a:fld id="{217FB9E2-7C0C-AB45-B0B4-06C6B1BD2B82}" type="slidenum">
-              <a:rPr lang="en-US" smtClean="0"/>
-              <a:pPr>
-                <a:defRPr/>
-              </a:pPr>
-              <a:t>10</a:t>
-            </a:fld>
-            <a:endParaRPr lang="en-US"/>
-          </a:p>
-        </p:txBody>
-      </p:sp>
-    </p:spTree>
-    <p:extLst>
-      <p:ext uri="{BB962C8B-B14F-4D97-AF65-F5344CB8AC3E}">
-        <p14:creationId xmlns:p14="http://schemas.microsoft.com/office/powerpoint/2010/main" val="3394856423"/>
-      </p:ext>
-    </p:extLst>
-  </p:cSld>
-  <p:clrMapOvr>
-    <a:masterClrMapping/>
-  </p:clrMapOvr>
-</p:notes>
-</file>
-
-<file path=ppt/notesSlides/notesSlide11.xml><?xml version="1.0" encoding="utf-8"?>
-<p:notes xmlns:a="http://schemas.openxmlformats.org/drawingml/2006/main" xmlns:r="http://schemas.openxmlformats.org/officeDocument/2006/relationships" xmlns:p="http://schemas.openxmlformats.org/presentationml/2006/main">
-  <p:cSld>
-    <p:spTree>
-      <p:nvGrpSpPr>
-        <p:cNvPr id="1" name=""/>
-        <p:cNvGrpSpPr/>
-        <p:nvPr/>
-      </p:nvGrpSpPr>
-      <p:grpSpPr>
-        <a:xfrm>
-          <a:off x="0" y="0"/>
-          <a:ext cx="0" cy="0"/>
-          <a:chOff x="0" y="0"/>
-          <a:chExt cx="0" cy="0"/>
-        </a:xfrm>
-      </p:grpSpPr>
-      <p:sp>
-        <p:nvSpPr>
-          <p:cNvPr id="2" name="Slide Image Placeholder 1"/>
-          <p:cNvSpPr>
-            <a:spLocks noGrp="1" noRot="1" noChangeAspect="1"/>
-          </p:cNvSpPr>
-          <p:nvPr>
-            <p:ph type="sldImg"/>
-          </p:nvPr>
-        </p:nvSpPr>
-        <p:spPr/>
-      </p:sp>
-      <p:sp>
-        <p:nvSpPr>
-          <p:cNvPr id="3" name="Notes Placeholder 2"/>
-          <p:cNvSpPr>
-            <a:spLocks noGrp="1"/>
-          </p:cNvSpPr>
-          <p:nvPr>
-            <p:ph type="body" idx="1"/>
-          </p:nvPr>
-        </p:nvSpPr>
-        <p:spPr/>
-        <p:txBody>
-          <a:bodyPr/>
-          <a:lstStyle/>
-          <a:p>
-            <a:endParaRPr lang="en-US"/>
-          </a:p>
-        </p:txBody>
-      </p:sp>
-      <p:sp>
-        <p:nvSpPr>
-          <p:cNvPr id="4" name="Slide Number Placeholder 3"/>
-          <p:cNvSpPr>
-            <a:spLocks noGrp="1"/>
-          </p:cNvSpPr>
-          <p:nvPr>
-            <p:ph type="sldNum" sz="quarter" idx="5"/>
-          </p:nvPr>
-        </p:nvSpPr>
-        <p:spPr/>
-        <p:txBody>
-          <a:bodyPr/>
-          <a:lstStyle/>
-          <a:p>
-            <a:fld id="{4218707C-A528-5347-B512-111D9A72273A}" type="slidenum">
-              <a:rPr lang="en-US" smtClean="0"/>
-              <a:t>11</a:t>
-            </a:fld>
-            <a:endParaRPr lang="en-US"/>
-          </a:p>
-        </p:txBody>
-      </p:sp>
-    </p:spTree>
-    <p:extLst>
-      <p:ext uri="{BB962C8B-B14F-4D97-AF65-F5344CB8AC3E}">
-        <p14:creationId xmlns:p14="http://schemas.microsoft.com/office/powerpoint/2010/main" val="1329077699"/>
-      </p:ext>
-    </p:extLst>
-  </p:cSld>
-  <p:clrMapOvr>
-    <a:masterClrMapping/>
-  </p:clrMapOvr>
-</p:notes>
-</file>
-
 <file path=ppt/notesSlides/notesSlide2.xml><?xml version="1.0" encoding="utf-8"?>
 <p:notes xmlns:a="http://schemas.openxmlformats.org/drawingml/2006/main" xmlns:r="http://schemas.openxmlformats.org/officeDocument/2006/relationships" xmlns:p="http://schemas.openxmlformats.org/presentationml/2006/main">
   <p:cSld>
@@ -877,24 +684,7 @@
           <a:bodyPr/>
           <a:lstStyle/>
           <a:p>
-            <a:endParaRPr lang="en-US" dirty="0"/>
-          </a:p>
-          <a:p>
-            <a:r>
-              <a:rPr lang="en-US" dirty="0"/>
-              <a:t>Changes in any attribute of a population over time. </a:t>
-            </a:r>
-          </a:p>
-          <a:p>
-            <a:r>
-              <a:rPr lang="en-US" dirty="0"/>
-              <a:t>Evolutionary</a:t>
-            </a:r>
-            <a:r>
-              <a:rPr lang="en-US" baseline="0" dirty="0"/>
-              <a:t> change leads to adaptation and must involve a change in the frequency of individual genes in a population from generation to generation.</a:t>
-            </a:r>
-            <a:endParaRPr lang="en-US" dirty="0"/>
+            <a:endParaRPr lang="en-US"/>
           </a:p>
         </p:txBody>
       </p:sp>
@@ -905,22 +695,16 @@
             <a:spLocks noGrp="1"/>
           </p:cNvSpPr>
           <p:nvPr>
-            <p:ph type="sldNum" sz="quarter" idx="10"/>
-          </p:nvPr>
-        </p:nvSpPr>
-        <p:spPr/>
-        <p:txBody>
-          <a:bodyPr/>
-          <a:lstStyle/>
-          <a:p>
-            <a:pPr>
-              <a:defRPr/>
-            </a:pPr>
-            <a:fld id="{217FB9E2-7C0C-AB45-B0B4-06C6B1BD2B82}" type="slidenum">
+            <p:ph type="sldNum" sz="quarter" idx="5"/>
+          </p:nvPr>
+        </p:nvSpPr>
+        <p:spPr/>
+        <p:txBody>
+          <a:bodyPr/>
+          <a:lstStyle/>
+          <a:p>
+            <a:fld id="{4218707C-A528-5347-B512-111D9A72273A}" type="slidenum">
               <a:rPr lang="en-US" smtClean="0"/>
-              <a:pPr>
-                <a:defRPr/>
-              </a:pPr>
               <a:t>3</a:t>
             </a:fld>
             <a:endParaRPr lang="en-US"/>
@@ -930,7 +714,7 @@
     </p:spTree>
     <p:extLst>
       <p:ext uri="{BB962C8B-B14F-4D97-AF65-F5344CB8AC3E}">
-        <p14:creationId xmlns:p14="http://schemas.microsoft.com/office/powerpoint/2010/main" val="1400352488"/>
+        <p14:creationId xmlns:p14="http://schemas.microsoft.com/office/powerpoint/2010/main" val="4152003408"/>
       </p:ext>
     </p:extLst>
   </p:cSld>
@@ -984,7 +768,16 @@
           <a:bodyPr/>
           <a:lstStyle/>
           <a:p>
-            <a:endParaRPr lang="en-US"/>
+            <a:r>
+              <a:rPr lang="en-US"/>
+              <a:t>Mosquito</a:t>
+            </a:r>
+          </a:p>
+          <a:p>
+            <a:r>
+              <a:rPr lang="en-US"/>
+              <a:t>https://www.polleverywhere.com/multiple_choice_polls/vjbNmi6kF7dtLLe6pw3o8?flow=Default&amp;onscreen=persist</a:t>
+            </a:r>
           </a:p>
         </p:txBody>
       </p:sp>
@@ -1014,7 +807,7 @@
     </p:spTree>
     <p:extLst>
       <p:ext uri="{BB962C8B-B14F-4D97-AF65-F5344CB8AC3E}">
-        <p14:creationId xmlns:p14="http://schemas.microsoft.com/office/powerpoint/2010/main" val="4152003408"/>
+        <p14:creationId xmlns:p14="http://schemas.microsoft.com/office/powerpoint/2010/main" val="3876120124"/>
       </p:ext>
     </p:extLst>
   </p:cSld>
@@ -1070,13 +863,13 @@
           <a:p>
             <a:r>
               <a:rPr lang="en-US"/>
-              <a:t>Mosquito</a:t>
-            </a:r>
-          </a:p>
-          <a:p>
-            <a:r>
-              <a:rPr lang="en-US"/>
-              <a:t>https://www.polleverywhere.com/multiple_choice_polls/vjbNmi6kF7dtLLe6pw3o8?flow=Default&amp;onscreen=persist</a:t>
+              <a:t>Tick</a:t>
+            </a:r>
+          </a:p>
+          <a:p>
+            <a:r>
+              <a:rPr lang="en-US"/>
+              <a:t>https://www.polleverywhere.com/multiple_choice_polls/PQ3rm4XTz3wLU2sjPXf8B?flow=Default&amp;onscreen=persist</a:t>
             </a:r>
           </a:p>
         </p:txBody>
@@ -1107,7 +900,7 @@
     </p:spTree>
     <p:extLst>
       <p:ext uri="{BB962C8B-B14F-4D97-AF65-F5344CB8AC3E}">
-        <p14:creationId xmlns:p14="http://schemas.microsoft.com/office/powerpoint/2010/main" val="3876120124"/>
+        <p14:creationId xmlns:p14="http://schemas.microsoft.com/office/powerpoint/2010/main" val="1676768030"/>
       </p:ext>
     </p:extLst>
   </p:cSld>
@@ -1163,13 +956,13 @@
           <a:p>
             <a:r>
               <a:rPr lang="en-US"/>
-              <a:t>Tick</a:t>
-            </a:r>
-          </a:p>
-          <a:p>
-            <a:r>
-              <a:rPr lang="en-US"/>
-              <a:t>https://www.polleverywhere.com/multiple_choice_polls/PQ3rm4XTz3wLU2sjPXf8B?flow=Default&amp;onscreen=persist</a:t>
+              <a:t>Body louse</a:t>
+            </a:r>
+          </a:p>
+          <a:p>
+            <a:r>
+              <a:rPr lang="en-US"/>
+              <a:t>https://www.polleverywhere.com/multiple_choice_polls/Ea7qNwU60hjsFocjTRzj8?flow=Default&amp;onscreen=persist</a:t>
             </a:r>
           </a:p>
         </p:txBody>
@@ -1200,7 +993,7 @@
     </p:spTree>
     <p:extLst>
       <p:ext uri="{BB962C8B-B14F-4D97-AF65-F5344CB8AC3E}">
-        <p14:creationId xmlns:p14="http://schemas.microsoft.com/office/powerpoint/2010/main" val="1676768030"/>
+        <p14:creationId xmlns:p14="http://schemas.microsoft.com/office/powerpoint/2010/main" val="890337557"/>
       </p:ext>
     </p:extLst>
   </p:cSld>
@@ -1256,13 +1049,13 @@
           <a:p>
             <a:r>
               <a:rPr lang="en-US"/>
-              <a:t>Body louse</a:t>
-            </a:r>
-          </a:p>
-          <a:p>
-            <a:r>
-              <a:rPr lang="en-US"/>
-              <a:t>https://www.polleverywhere.com/multiple_choice_polls/Ea7qNwU60hjsFocjTRzj8?flow=Default&amp;onscreen=persist</a:t>
+              <a:t>Deer fly</a:t>
+            </a:r>
+          </a:p>
+          <a:p>
+            <a:r>
+              <a:rPr lang="en-US"/>
+              <a:t>https://www.polleverywhere.com/multiple_choice_polls/J5mY1d2c8G8x3H7wL6mHA?flow=Default&amp;onscreen=persist</a:t>
             </a:r>
           </a:p>
         </p:txBody>
@@ -1293,7 +1086,7 @@
     </p:spTree>
     <p:extLst>
       <p:ext uri="{BB962C8B-B14F-4D97-AF65-F5344CB8AC3E}">
-        <p14:creationId xmlns:p14="http://schemas.microsoft.com/office/powerpoint/2010/main" val="890337557"/>
+        <p14:creationId xmlns:p14="http://schemas.microsoft.com/office/powerpoint/2010/main" val="2470125437"/>
       </p:ext>
     </p:extLst>
   </p:cSld>
@@ -1347,16 +1140,7 @@
           <a:bodyPr/>
           <a:lstStyle/>
           <a:p>
-            <a:r>
-              <a:rPr lang="en-US"/>
-              <a:t>Deer fly</a:t>
-            </a:r>
-          </a:p>
-          <a:p>
-            <a:r>
-              <a:rPr lang="en-US"/>
-              <a:t>https://www.polleverywhere.com/multiple_choice_polls/J5mY1d2c8G8x3H7wL6mHA?flow=Default&amp;onscreen=persist</a:t>
-            </a:r>
+            <a:endParaRPr lang="en-US"/>
           </a:p>
         </p:txBody>
       </p:sp>
@@ -1386,7 +1170,7 @@
     </p:spTree>
     <p:extLst>
       <p:ext uri="{BB962C8B-B14F-4D97-AF65-F5344CB8AC3E}">
-        <p14:creationId xmlns:p14="http://schemas.microsoft.com/office/powerpoint/2010/main" val="2470125437"/>
+        <p14:creationId xmlns:p14="http://schemas.microsoft.com/office/powerpoint/2010/main" val="3291845355"/>
       </p:ext>
     </p:extLst>
   </p:cSld>
@@ -1470,7 +1254,7 @@
     </p:spTree>
     <p:extLst>
       <p:ext uri="{BB962C8B-B14F-4D97-AF65-F5344CB8AC3E}">
-        <p14:creationId xmlns:p14="http://schemas.microsoft.com/office/powerpoint/2010/main" val="3291845355"/>
+        <p14:creationId xmlns:p14="http://schemas.microsoft.com/office/powerpoint/2010/main" val="1329077699"/>
       </p:ext>
     </p:extLst>
   </p:cSld>
@@ -1627,7 +1411,7 @@
           <a:p>
             <a:fld id="{21DDE3A9-9D48-7D40-AF95-520AE186EA5D}" type="datetimeFigureOut">
               <a:rPr lang="en-US" smtClean="0"/>
-              <a:t>11/3/21</a:t>
+              <a:t>11/3/25</a:t>
             </a:fld>
             <a:endParaRPr lang="en-US"/>
           </a:p>
@@ -1825,7 +1609,7 @@
           <a:p>
             <a:fld id="{21DDE3A9-9D48-7D40-AF95-520AE186EA5D}" type="datetimeFigureOut">
               <a:rPr lang="en-US" smtClean="0"/>
-              <a:t>11/3/21</a:t>
+              <a:t>11/3/25</a:t>
             </a:fld>
             <a:endParaRPr lang="en-US"/>
           </a:p>
@@ -2033,7 +1817,7 @@
           <a:p>
             <a:fld id="{21DDE3A9-9D48-7D40-AF95-520AE186EA5D}" type="datetimeFigureOut">
               <a:rPr lang="en-US" smtClean="0"/>
-              <a:t>11/3/21</a:t>
+              <a:t>11/3/25</a:t>
             </a:fld>
             <a:endParaRPr lang="en-US"/>
           </a:p>
@@ -2231,7 +2015,7 @@
           <a:p>
             <a:fld id="{21DDE3A9-9D48-7D40-AF95-520AE186EA5D}" type="datetimeFigureOut">
               <a:rPr lang="en-US" smtClean="0"/>
-              <a:t>11/3/21</a:t>
+              <a:t>11/3/25</a:t>
             </a:fld>
             <a:endParaRPr lang="en-US"/>
           </a:p>
@@ -2506,7 +2290,7 @@
           <a:p>
             <a:fld id="{21DDE3A9-9D48-7D40-AF95-520AE186EA5D}" type="datetimeFigureOut">
               <a:rPr lang="en-US" smtClean="0"/>
-              <a:t>11/3/21</a:t>
+              <a:t>11/3/25</a:t>
             </a:fld>
             <a:endParaRPr lang="en-US"/>
           </a:p>
@@ -2771,7 +2555,7 @@
           <a:p>
             <a:fld id="{21DDE3A9-9D48-7D40-AF95-520AE186EA5D}" type="datetimeFigureOut">
               <a:rPr lang="en-US" smtClean="0"/>
-              <a:t>11/3/21</a:t>
+              <a:t>11/3/25</a:t>
             </a:fld>
             <a:endParaRPr lang="en-US"/>
           </a:p>
@@ -3183,7 +2967,7 @@
           <a:p>
             <a:fld id="{21DDE3A9-9D48-7D40-AF95-520AE186EA5D}" type="datetimeFigureOut">
               <a:rPr lang="en-US" smtClean="0"/>
-              <a:t>11/3/21</a:t>
+              <a:t>11/3/25</a:t>
             </a:fld>
             <a:endParaRPr lang="en-US"/>
           </a:p>
@@ -3324,7 +3108,7 @@
           <a:p>
             <a:fld id="{21DDE3A9-9D48-7D40-AF95-520AE186EA5D}" type="datetimeFigureOut">
               <a:rPr lang="en-US" smtClean="0"/>
-              <a:t>11/3/21</a:t>
+              <a:t>11/3/25</a:t>
             </a:fld>
             <a:endParaRPr lang="en-US"/>
           </a:p>
@@ -3437,7 +3221,7 @@
           <a:p>
             <a:fld id="{21DDE3A9-9D48-7D40-AF95-520AE186EA5D}" type="datetimeFigureOut">
               <a:rPr lang="en-US" smtClean="0"/>
-              <a:t>11/3/21</a:t>
+              <a:t>11/3/25</a:t>
             </a:fld>
             <a:endParaRPr lang="en-US"/>
           </a:p>
@@ -3748,7 +3532,7 @@
           <a:p>
             <a:fld id="{21DDE3A9-9D48-7D40-AF95-520AE186EA5D}" type="datetimeFigureOut">
               <a:rPr lang="en-US" smtClean="0"/>
-              <a:t>11/3/21</a:t>
+              <a:t>11/3/25</a:t>
             </a:fld>
             <a:endParaRPr lang="en-US"/>
           </a:p>
@@ -4036,7 +3820,7 @@
           <a:p>
             <a:fld id="{21DDE3A9-9D48-7D40-AF95-520AE186EA5D}" type="datetimeFigureOut">
               <a:rPr lang="en-US" smtClean="0"/>
-              <a:t>11/3/21</a:t>
+              <a:t>11/3/25</a:t>
             </a:fld>
             <a:endParaRPr lang="en-US"/>
           </a:p>
@@ -4277,7 +4061,7 @@
           <a:p>
             <a:fld id="{21DDE3A9-9D48-7D40-AF95-520AE186EA5D}" type="datetimeFigureOut">
               <a:rPr lang="en-US" smtClean="0"/>
-              <a:t>11/3/21</a:t>
+              <a:t>11/3/25</a:t>
             </a:fld>
             <a:endParaRPr lang="en-US"/>
           </a:p>
@@ -4746,7 +4530,7 @@
                 <a:latin typeface="Avenir Book" panose="02000503020000020003" pitchFamily="2" charset="0"/>
                 <a:cs typeface="Avenir"/>
               </a:rPr>
-              <a:t>Practical session 15</a:t>
+              <a:t>Class 15</a:t>
             </a:r>
             <a:r>
               <a:rPr lang="en-US" sz="4800" dirty="0">
@@ -4777,266 +4561,6 @@
     <p:extLst>
       <p:ext uri="{BB962C8B-B14F-4D97-AF65-F5344CB8AC3E}">
         <p14:creationId xmlns:p14="http://schemas.microsoft.com/office/powerpoint/2010/main" val="1116647298"/>
-      </p:ext>
-    </p:extLst>
-  </p:cSld>
-  <p:clrMapOvr>
-    <a:masterClrMapping/>
-  </p:clrMapOvr>
-</p:sld>
-</file>
-
-<file path=ppt/slides/slide10.xml><?xml version="1.0" encoding="utf-8"?>
-<p:sld xmlns:a="http://schemas.openxmlformats.org/drawingml/2006/main" xmlns:r="http://schemas.openxmlformats.org/officeDocument/2006/relationships" xmlns:p="http://schemas.openxmlformats.org/presentationml/2006/main">
-  <p:cSld>
-    <p:spTree>
-      <p:nvGrpSpPr>
-        <p:cNvPr id="1" name=""/>
-        <p:cNvGrpSpPr/>
-        <p:nvPr/>
-      </p:nvGrpSpPr>
-      <p:grpSpPr>
-        <a:xfrm>
-          <a:off x="0" y="0"/>
-          <a:ext cx="0" cy="0"/>
-          <a:chOff x="0" y="0"/>
-          <a:chExt cx="0" cy="0"/>
-        </a:xfrm>
-      </p:grpSpPr>
-      <p:pic>
-        <p:nvPicPr>
-          <p:cNvPr id="5" name="Picture 4">
-            <a:extLst>
-              <a:ext uri="{FF2B5EF4-FFF2-40B4-BE49-F238E27FC236}">
-                <a16:creationId xmlns:a16="http://schemas.microsoft.com/office/drawing/2014/main" id="{C8F37AE3-B782-4641-8C9A-7A9115E2FD8D}"/>
-              </a:ext>
-            </a:extLst>
-          </p:cNvPr>
-          <p:cNvPicPr>
-            <a:picLocks noChangeAspect="1"/>
-          </p:cNvPicPr>
-          <p:nvPr/>
-        </p:nvPicPr>
-        <p:blipFill rotWithShape="1">
-          <a:blip r:embed="rId3"/>
-          <a:srcRect l="6978" t="6285" r="7095" b="7757"/>
-          <a:stretch/>
-        </p:blipFill>
-        <p:spPr>
-          <a:xfrm>
-            <a:off x="1128713" y="128588"/>
-            <a:ext cx="9929812" cy="6615541"/>
-          </a:xfrm>
-          <a:prstGeom prst="rect">
-            <a:avLst/>
-          </a:prstGeom>
-        </p:spPr>
-      </p:pic>
-      <p:sp>
-        <p:nvSpPr>
-          <p:cNvPr id="6" name="Rectangle 5">
-            <a:extLst>
-              <a:ext uri="{FF2B5EF4-FFF2-40B4-BE49-F238E27FC236}">
-                <a16:creationId xmlns:a16="http://schemas.microsoft.com/office/drawing/2014/main" id="{23668B0C-F122-1346-BD94-04D4F7A74C1B}"/>
-              </a:ext>
-            </a:extLst>
-          </p:cNvPr>
-          <p:cNvSpPr>
-            <a:spLocks noChangeArrowheads="1"/>
-          </p:cNvSpPr>
-          <p:nvPr/>
-        </p:nvSpPr>
-        <p:spPr bwMode="auto">
-          <a:xfrm>
-            <a:off x="312470" y="376970"/>
-            <a:ext cx="11567060" cy="1169551"/>
-          </a:xfrm>
-          <a:prstGeom prst="rect">
-            <a:avLst/>
-          </a:prstGeom>
-          <a:noFill/>
-          <a:ln w="9525">
-            <a:noFill/>
-            <a:miter lim="800000"/>
-            <a:headEnd/>
-            <a:tailEnd/>
-          </a:ln>
-          <a:effectLst/>
-        </p:spPr>
-        <p:txBody>
-          <a:bodyPr wrap="square">
-            <a:spAutoFit/>
-          </a:bodyPr>
-          <a:lstStyle/>
-          <a:p>
-            <a:pPr algn="ctr">
-              <a:defRPr/>
-            </a:pPr>
-            <a:r>
-              <a:rPr lang="en-US" sz="3500" b="1" dirty="0">
-                <a:latin typeface="Avenir"/>
-                <a:cs typeface="Avenir"/>
-              </a:rPr>
-              <a:t>Q3. why are are so many </a:t>
-            </a:r>
-            <a:r>
-              <a:rPr lang="en-US" sz="3500" b="1" dirty="0" err="1">
-                <a:latin typeface="Avenir"/>
-                <a:cs typeface="Avenir"/>
-              </a:rPr>
-              <a:t>micropredators</a:t>
-            </a:r>
-            <a:r>
-              <a:rPr lang="en-US" sz="3500" b="1" dirty="0">
-                <a:latin typeface="Avenir"/>
-                <a:cs typeface="Avenir"/>
-              </a:rPr>
-              <a:t> </a:t>
-            </a:r>
-          </a:p>
-          <a:p>
-            <a:pPr algn="ctr">
-              <a:defRPr/>
-            </a:pPr>
-            <a:r>
-              <a:rPr lang="en-US" sz="3500" b="1" dirty="0">
-                <a:latin typeface="Avenir"/>
-                <a:cs typeface="Avenir"/>
-              </a:rPr>
-              <a:t>also vectors?</a:t>
-            </a:r>
-            <a:endParaRPr lang="en-US" sz="3500" b="1" i="1" dirty="0">
-              <a:latin typeface="Avenir"/>
-              <a:cs typeface="Avenir"/>
-            </a:endParaRPr>
-          </a:p>
-        </p:txBody>
-      </p:sp>
-    </p:spTree>
-    <p:extLst>
-      <p:ext uri="{BB962C8B-B14F-4D97-AF65-F5344CB8AC3E}">
-        <p14:creationId xmlns:p14="http://schemas.microsoft.com/office/powerpoint/2010/main" val="404441363"/>
-      </p:ext>
-    </p:extLst>
-  </p:cSld>
-  <p:clrMapOvr>
-    <a:masterClrMapping/>
-  </p:clrMapOvr>
-</p:sld>
-</file>
-
-<file path=ppt/slides/slide11.xml><?xml version="1.0" encoding="utf-8"?>
-<p:sld xmlns:a="http://schemas.openxmlformats.org/drawingml/2006/main" xmlns:r="http://schemas.openxmlformats.org/officeDocument/2006/relationships" xmlns:p="http://schemas.openxmlformats.org/presentationml/2006/main">
-  <p:cSld>
-    <p:bg>
-      <p:bgPr>
-        <a:solidFill>
-          <a:schemeClr val="tx1"/>
-        </a:solidFill>
-        <a:effectLst/>
-      </p:bgPr>
-    </p:bg>
-    <p:spTree>
-      <p:nvGrpSpPr>
-        <p:cNvPr id="1" name=""/>
-        <p:cNvGrpSpPr/>
-        <p:nvPr/>
-      </p:nvGrpSpPr>
-      <p:grpSpPr>
-        <a:xfrm>
-          <a:off x="0" y="0"/>
-          <a:ext cx="0" cy="0"/>
-          <a:chOff x="0" y="0"/>
-          <a:chExt cx="0" cy="0"/>
-        </a:xfrm>
-      </p:grpSpPr>
-      <p:sp>
-        <p:nvSpPr>
-          <p:cNvPr id="2" name="Rectangle 2"/>
-          <p:cNvSpPr>
-            <a:spLocks noChangeArrowheads="1"/>
-          </p:cNvSpPr>
-          <p:nvPr/>
-        </p:nvSpPr>
-        <p:spPr bwMode="auto">
-          <a:xfrm>
-            <a:off x="239635" y="2644170"/>
-            <a:ext cx="10896600" cy="1569660"/>
-          </a:xfrm>
-          <a:prstGeom prst="rect">
-            <a:avLst/>
-          </a:prstGeom>
-          <a:noFill/>
-          <a:ln w="9525">
-            <a:noFill/>
-            <a:miter lim="800000"/>
-            <a:headEnd/>
-            <a:tailEnd/>
-          </a:ln>
-          <a:effectLst/>
-        </p:spPr>
-        <p:txBody>
-          <a:bodyPr wrap="square">
-            <a:spAutoFit/>
-          </a:bodyPr>
-          <a:lstStyle/>
-          <a:p>
-            <a:pPr>
-              <a:defRPr/>
-            </a:pPr>
-            <a:r>
-              <a:rPr lang="en-US" sz="4800" b="1" dirty="0">
-                <a:solidFill>
-                  <a:schemeClr val="bg1">
-                    <a:lumMod val="65000"/>
-                  </a:schemeClr>
-                </a:solidFill>
-                <a:latin typeface="Avenir Book" panose="02000503020000020003" pitchFamily="2" charset="0"/>
-                <a:cs typeface="Avenir"/>
-              </a:rPr>
-              <a:t>Practical </a:t>
-            </a:r>
-            <a:r>
-              <a:rPr lang="en-US" sz="4800" b="1">
-                <a:solidFill>
-                  <a:schemeClr val="bg1">
-                    <a:lumMod val="65000"/>
-                  </a:schemeClr>
-                </a:solidFill>
-                <a:latin typeface="Avenir Book" panose="02000503020000020003" pitchFamily="2" charset="0"/>
-                <a:cs typeface="Avenir"/>
-              </a:rPr>
-              <a:t>session 15</a:t>
-            </a:r>
-            <a:r>
-              <a:rPr lang="en-US" sz="4800">
-                <a:solidFill>
-                  <a:schemeClr val="bg1">
-                    <a:lumMod val="65000"/>
-                  </a:schemeClr>
-                </a:solidFill>
-                <a:latin typeface="Avenir Book" panose="02000503020000020003" pitchFamily="2" charset="0"/>
-                <a:cs typeface="Avenir"/>
-              </a:rPr>
-              <a:t>: </a:t>
-            </a:r>
-            <a:r>
-              <a:rPr lang="en-US" sz="4800" dirty="0">
-                <a:solidFill>
-                  <a:srgbClr val="FFFFFF"/>
-                </a:solidFill>
-                <a:latin typeface="Avenir Book" panose="02000503020000020003" pitchFamily="2" charset="0"/>
-                <a:cs typeface="Avenir"/>
-              </a:rPr>
-              <a:t>Introduction to the arthropods</a:t>
-            </a:r>
-          </a:p>
-        </p:txBody>
-      </p:sp>
-    </p:spTree>
-    <p:extLst>
-      <p:ext uri="{BB962C8B-B14F-4D97-AF65-F5344CB8AC3E}">
-        <p14:creationId xmlns:p14="http://schemas.microsoft.com/office/powerpoint/2010/main" val="1664332766"/>
       </p:ext>
     </p:extLst>
   </p:cSld>
@@ -5467,131 +4991,6 @@
           <a:chExt cx="0" cy="0"/>
         </a:xfrm>
       </p:grpSpPr>
-      <p:pic>
-        <p:nvPicPr>
-          <p:cNvPr id="5" name="Picture 4">
-            <a:extLst>
-              <a:ext uri="{FF2B5EF4-FFF2-40B4-BE49-F238E27FC236}">
-                <a16:creationId xmlns:a16="http://schemas.microsoft.com/office/drawing/2014/main" id="{C8F37AE3-B782-4641-8C9A-7A9115E2FD8D}"/>
-              </a:ext>
-            </a:extLst>
-          </p:cNvPr>
-          <p:cNvPicPr>
-            <a:picLocks noChangeAspect="1"/>
-          </p:cNvPicPr>
-          <p:nvPr/>
-        </p:nvPicPr>
-        <p:blipFill rotWithShape="1">
-          <a:blip r:embed="rId3"/>
-          <a:srcRect l="6978" t="6285" r="7095" b="7757"/>
-          <a:stretch/>
-        </p:blipFill>
-        <p:spPr>
-          <a:xfrm>
-            <a:off x="1128713" y="128588"/>
-            <a:ext cx="9929812" cy="6615541"/>
-          </a:xfrm>
-          <a:prstGeom prst="rect">
-            <a:avLst/>
-          </a:prstGeom>
-        </p:spPr>
-      </p:pic>
-      <p:sp>
-        <p:nvSpPr>
-          <p:cNvPr id="8" name="Rectangle 7">
-            <a:extLst>
-              <a:ext uri="{FF2B5EF4-FFF2-40B4-BE49-F238E27FC236}">
-                <a16:creationId xmlns:a16="http://schemas.microsoft.com/office/drawing/2014/main" id="{0CF29BF3-CEB0-EA4A-B7EE-5C9405D94A70}"/>
-              </a:ext>
-            </a:extLst>
-          </p:cNvPr>
-          <p:cNvSpPr>
-            <a:spLocks noChangeArrowheads="1"/>
-          </p:cNvSpPr>
-          <p:nvPr/>
-        </p:nvSpPr>
-        <p:spPr bwMode="auto">
-          <a:xfrm>
-            <a:off x="541339" y="263318"/>
-            <a:ext cx="11109322" cy="1169551"/>
-          </a:xfrm>
-          <a:prstGeom prst="rect">
-            <a:avLst/>
-          </a:prstGeom>
-          <a:noFill/>
-          <a:ln w="9525">
-            <a:noFill/>
-            <a:miter lim="800000"/>
-            <a:headEnd/>
-            <a:tailEnd/>
-          </a:ln>
-          <a:effectLst/>
-        </p:spPr>
-        <p:txBody>
-          <a:bodyPr wrap="square">
-            <a:spAutoFit/>
-          </a:bodyPr>
-          <a:lstStyle/>
-          <a:p>
-            <a:pPr algn="ctr">
-              <a:defRPr/>
-            </a:pPr>
-            <a:r>
-              <a:rPr lang="en-US" sz="3500" b="1" dirty="0">
-                <a:latin typeface="Avenir"/>
-                <a:cs typeface="Avenir"/>
-              </a:rPr>
-              <a:t>Q1. why is Lyme disease increasing </a:t>
-            </a:r>
-          </a:p>
-          <a:p>
-            <a:pPr algn="ctr">
-              <a:defRPr/>
-            </a:pPr>
-            <a:r>
-              <a:rPr lang="en-US" sz="3500" b="1" dirty="0">
-                <a:latin typeface="Avenir"/>
-                <a:cs typeface="Avenir"/>
-              </a:rPr>
-              <a:t>in the US?</a:t>
-            </a:r>
-            <a:endParaRPr lang="en-US" sz="3500" b="1" i="1" dirty="0">
-              <a:latin typeface="Avenir"/>
-              <a:cs typeface="Avenir"/>
-            </a:endParaRPr>
-          </a:p>
-        </p:txBody>
-      </p:sp>
-    </p:spTree>
-    <p:extLst>
-      <p:ext uri="{BB962C8B-B14F-4D97-AF65-F5344CB8AC3E}">
-        <p14:creationId xmlns:p14="http://schemas.microsoft.com/office/powerpoint/2010/main" val="2316116945"/>
-      </p:ext>
-    </p:extLst>
-  </p:cSld>
-  <p:clrMapOvr>
-    <a:masterClrMapping/>
-  </p:clrMapOvr>
-</p:sld>
-</file>
-
-<file path=ppt/slides/slide4.xml><?xml version="1.0" encoding="utf-8"?>
-<p:sld xmlns:a="http://schemas.openxmlformats.org/drawingml/2006/main" xmlns:r="http://schemas.openxmlformats.org/officeDocument/2006/relationships" xmlns:p="http://schemas.openxmlformats.org/presentationml/2006/main">
-  <p:cSld>
-    <p:spTree>
-      <p:nvGrpSpPr>
-        <p:cNvPr id="1" name=""/>
-        <p:cNvGrpSpPr/>
-        <p:nvPr/>
-      </p:nvGrpSpPr>
-      <p:grpSpPr>
-        <a:xfrm>
-          <a:off x="0" y="0"/>
-          <a:ext cx="0" cy="0"/>
-          <a:chOff x="0" y="0"/>
-          <a:chExt cx="0" cy="0"/>
-        </a:xfrm>
-      </p:grpSpPr>
       <p:sp>
         <p:nvSpPr>
           <p:cNvPr id="3" name="Rectangle 2"/>
@@ -5721,7 +5120,7 @@
 </p:sld>
 </file>
 
-<file path=ppt/slides/slide5.xml><?xml version="1.0" encoding="utf-8"?>
+<file path=ppt/slides/slide4.xml><?xml version="1.0" encoding="utf-8"?>
 <p:sld xmlns:a="http://schemas.openxmlformats.org/drawingml/2006/main" xmlns:r="http://schemas.openxmlformats.org/officeDocument/2006/relationships" xmlns:p="http://schemas.openxmlformats.org/presentationml/2006/main">
   <p:cSld>
     <p:spTree>
@@ -5831,7 +5230,7 @@
 </p:sld>
 </file>
 
-<file path=ppt/slides/slide6.xml><?xml version="1.0" encoding="utf-8"?>
+<file path=ppt/slides/slide5.xml><?xml version="1.0" encoding="utf-8"?>
 <p:sld xmlns:a="http://schemas.openxmlformats.org/drawingml/2006/main" xmlns:r="http://schemas.openxmlformats.org/officeDocument/2006/relationships" xmlns:p="http://schemas.openxmlformats.org/presentationml/2006/main">
   <p:cSld>
     <p:spTree>
@@ -5941,7 +5340,7 @@
 </p:sld>
 </file>
 
-<file path=ppt/slides/slide7.xml><?xml version="1.0" encoding="utf-8"?>
+<file path=ppt/slides/slide6.xml><?xml version="1.0" encoding="utf-8"?>
 <p:sld xmlns:a="http://schemas.openxmlformats.org/drawingml/2006/main" xmlns:r="http://schemas.openxmlformats.org/officeDocument/2006/relationships" xmlns:p="http://schemas.openxmlformats.org/presentationml/2006/main">
   <p:cSld>
     <p:spTree>
@@ -6051,7 +5450,7 @@
 </p:sld>
 </file>
 
-<file path=ppt/slides/slide8.xml><?xml version="1.0" encoding="utf-8"?>
+<file path=ppt/slides/slide7.xml><?xml version="1.0" encoding="utf-8"?>
 <p:sld xmlns:a="http://schemas.openxmlformats.org/drawingml/2006/main" xmlns:r="http://schemas.openxmlformats.org/officeDocument/2006/relationships" xmlns:p="http://schemas.openxmlformats.org/presentationml/2006/main">
   <p:cSld>
     <p:spTree>
@@ -6161,7 +5560,7 @@
 </p:sld>
 </file>
 
-<file path=ppt/slides/slide9.xml><?xml version="1.0" encoding="utf-8"?>
+<file path=ppt/slides/slide8.xml><?xml version="1.0" encoding="utf-8"?>
 <p:sld xmlns:a="http://schemas.openxmlformats.org/drawingml/2006/main" xmlns:r="http://schemas.openxmlformats.org/officeDocument/2006/relationships" xmlns:p="http://schemas.openxmlformats.org/presentationml/2006/main">
   <p:cSld>
     <p:spTree>
@@ -6613,6 +6012,115 @@
       <p:bldP spid="4" grpId="0" uiExpand="1" build="p" bldLvl="5"/>
     </p:bldLst>
   </p:timing>
+</p:sld>
+</file>
+
+<file path=ppt/slides/slide9.xml><?xml version="1.0" encoding="utf-8"?>
+<p:sld xmlns:a="http://schemas.openxmlformats.org/drawingml/2006/main" xmlns:r="http://schemas.openxmlformats.org/officeDocument/2006/relationships" xmlns:p="http://schemas.openxmlformats.org/presentationml/2006/main">
+  <p:cSld>
+    <p:bg>
+      <p:bgPr>
+        <a:solidFill>
+          <a:schemeClr val="tx1"/>
+        </a:solidFill>
+        <a:effectLst/>
+      </p:bgPr>
+    </p:bg>
+    <p:spTree>
+      <p:nvGrpSpPr>
+        <p:cNvPr id="1" name=""/>
+        <p:cNvGrpSpPr/>
+        <p:nvPr/>
+      </p:nvGrpSpPr>
+      <p:grpSpPr>
+        <a:xfrm>
+          <a:off x="0" y="0"/>
+          <a:ext cx="0" cy="0"/>
+          <a:chOff x="0" y="0"/>
+          <a:chExt cx="0" cy="0"/>
+        </a:xfrm>
+      </p:grpSpPr>
+      <p:sp>
+        <p:nvSpPr>
+          <p:cNvPr id="2" name="Rectangle 2"/>
+          <p:cNvSpPr>
+            <a:spLocks noChangeArrowheads="1"/>
+          </p:cNvSpPr>
+          <p:nvPr/>
+        </p:nvSpPr>
+        <p:spPr bwMode="auto">
+          <a:xfrm>
+            <a:off x="239635" y="2644170"/>
+            <a:ext cx="10896600" cy="1569660"/>
+          </a:xfrm>
+          <a:prstGeom prst="rect">
+            <a:avLst/>
+          </a:prstGeom>
+          <a:noFill/>
+          <a:ln w="9525">
+            <a:noFill/>
+            <a:miter lim="800000"/>
+            <a:headEnd/>
+            <a:tailEnd/>
+          </a:ln>
+          <a:effectLst/>
+        </p:spPr>
+        <p:txBody>
+          <a:bodyPr wrap="square">
+            <a:spAutoFit/>
+          </a:bodyPr>
+          <a:lstStyle/>
+          <a:p>
+            <a:pPr>
+              <a:defRPr/>
+            </a:pPr>
+            <a:r>
+              <a:rPr lang="en-US" sz="4800" b="1" dirty="0">
+                <a:solidFill>
+                  <a:schemeClr val="bg1">
+                    <a:lumMod val="65000"/>
+                  </a:schemeClr>
+                </a:solidFill>
+                <a:latin typeface="Avenir Book" panose="02000503020000020003" pitchFamily="2" charset="0"/>
+                <a:cs typeface="Avenir"/>
+              </a:rPr>
+              <a:t>Class 15</a:t>
+            </a:r>
+            <a:r>
+              <a:rPr lang="en-US" sz="4800" dirty="0">
+                <a:solidFill>
+                  <a:schemeClr val="bg1">
+                    <a:lumMod val="65000"/>
+                  </a:schemeClr>
+                </a:solidFill>
+                <a:latin typeface="Avenir Book" panose="02000503020000020003" pitchFamily="2" charset="0"/>
+                <a:cs typeface="Avenir"/>
+              </a:rPr>
+              <a:t>: </a:t>
+            </a:r>
+            <a:r>
+              <a:rPr lang="en-US" sz="4800" dirty="0">
+                <a:solidFill>
+                  <a:srgbClr val="FFFFFF"/>
+                </a:solidFill>
+                <a:latin typeface="Avenir Book" panose="02000503020000020003" pitchFamily="2" charset="0"/>
+                <a:cs typeface="Avenir"/>
+              </a:rPr>
+              <a:t>Introduction to the arthropods</a:t>
+            </a:r>
+          </a:p>
+        </p:txBody>
+      </p:sp>
+    </p:spTree>
+    <p:extLst>
+      <p:ext uri="{BB962C8B-B14F-4D97-AF65-F5344CB8AC3E}">
+        <p14:creationId xmlns:p14="http://schemas.microsoft.com/office/powerpoint/2010/main" val="1664332766"/>
+      </p:ext>
+    </p:extLst>
+  </p:cSld>
+  <p:clrMapOvr>
+    <a:masterClrMapping/>
+  </p:clrMapOvr>
 </p:sld>
 </file>
 

</xml_diff>